<commit_message>
Color Checker Guide Update
</commit_message>
<xml_diff>
--- a/Documents/Original/FlexChroma_Blend_Color_Checker-JP.pptx
+++ b/Documents/Original/FlexChroma_Blend_Color_Checker-JP.pptx
@@ -16329,7 +16329,7 @@
               <a:buAutoNum type="arabicPeriod"/>
             </a:pPr>
             <a:r>
-              <a:rPr lang="en-US" sz="1000">
+              <a:rPr lang="en-US" sz="1000" dirty="0">
                 <a:solidFill>
                   <a:schemeClr val="dk1"/>
                 </a:solidFill>
@@ -16340,7 +16340,7 @@
               </a:rPr>
               <a:t>欲しい色を実現できそうな2色のフィラメントを選定する </a:t>
             </a:r>
-            <a:endParaRPr sz="1000">
+            <a:endParaRPr sz="1000" dirty="0">
               <a:solidFill>
                 <a:schemeClr val="dk1"/>
               </a:solidFill>
@@ -16369,18 +16369,42 @@
               <a:buAutoNum type="arabicPeriod"/>
             </a:pPr>
             <a:r>
-              <a:rPr lang="en-US" sz="1000">
-                <a:solidFill>
-                  <a:schemeClr val="dk1"/>
-                </a:solidFill>
-                <a:latin typeface="IBM Plex Sans JP" panose="020B0503050203000203" pitchFamily="50" charset="-128"/>
-                <a:ea typeface="IBM Plex Sans JP" panose="020B0503050203000203" pitchFamily="50" charset="-128"/>
-                <a:cs typeface="IBM Plex Sans JP"/>
-                <a:sym typeface="IBM Plex Sans JP"/>
-              </a:rPr>
-              <a:t>1のフィラメントを用いてCheck Filament を印刷する </a:t>
-            </a:r>
-            <a:endParaRPr sz="1000">
+              <a:rPr lang="en-US" sz="1000" dirty="0">
+                <a:solidFill>
+                  <a:schemeClr val="dk1"/>
+                </a:solidFill>
+                <a:latin typeface="IBM Plex Sans JP" panose="020B0503050203000203" pitchFamily="50" charset="-128"/>
+                <a:ea typeface="IBM Plex Sans JP" panose="020B0503050203000203" pitchFamily="50" charset="-128"/>
+                <a:cs typeface="IBM Plex Sans JP"/>
+                <a:sym typeface="IBM Plex Sans JP"/>
+              </a:rPr>
+              <a:t>1のフィラメントを用いてCheck Filament </a:t>
+            </a:r>
+            <a:r>
+              <a:rPr lang="en-US" sz="1000" dirty="0" err="1">
+                <a:solidFill>
+                  <a:schemeClr val="dk1"/>
+                </a:solidFill>
+                <a:latin typeface="IBM Plex Sans JP" panose="020B0503050203000203" pitchFamily="50" charset="-128"/>
+                <a:ea typeface="IBM Plex Sans JP" panose="020B0503050203000203" pitchFamily="50" charset="-128"/>
+                <a:cs typeface="IBM Plex Sans JP"/>
+                <a:sym typeface="IBM Plex Sans JP"/>
+              </a:rPr>
+              <a:t>を印刷する</a:t>
+            </a:r>
+            <a:r>
+              <a:rPr lang="en-US" sz="1000" dirty="0">
+                <a:solidFill>
+                  <a:schemeClr val="dk1"/>
+                </a:solidFill>
+                <a:latin typeface="IBM Plex Sans JP" panose="020B0503050203000203" pitchFamily="50" charset="-128"/>
+                <a:ea typeface="IBM Plex Sans JP" panose="020B0503050203000203" pitchFamily="50" charset="-128"/>
+                <a:cs typeface="IBM Plex Sans JP"/>
+                <a:sym typeface="IBM Plex Sans JP"/>
+              </a:rPr>
+              <a:t> </a:t>
+            </a:r>
+            <a:endParaRPr sz="1000" dirty="0">
               <a:solidFill>
                 <a:schemeClr val="dk1"/>
               </a:solidFill>
@@ -16409,18 +16433,66 @@
               <a:buAutoNum type="arabicPeriod"/>
             </a:pPr>
             <a:r>
-              <a:rPr lang="en-US" sz="1000">
-                <a:solidFill>
-                  <a:schemeClr val="dk1"/>
-                </a:solidFill>
-                <a:latin typeface="IBM Plex Sans JP" panose="020B0503050203000203" pitchFamily="50" charset="-128"/>
-                <a:ea typeface="IBM Plex Sans JP" panose="020B0503050203000203" pitchFamily="50" charset="-128"/>
-                <a:cs typeface="IBM Plex Sans JP"/>
-                <a:sym typeface="IBM Plex Sans JP"/>
-              </a:rPr>
-              <a:t>Check Filament によってCheck Tower を印刷し、求める色に近いう混合比を確認する </a:t>
-            </a:r>
-            <a:endParaRPr sz="1000">
+              <a:rPr lang="en-US" sz="1000" dirty="0">
+                <a:solidFill>
+                  <a:schemeClr val="dk1"/>
+                </a:solidFill>
+                <a:latin typeface="IBM Plex Sans JP" panose="020B0503050203000203" pitchFamily="50" charset="-128"/>
+                <a:ea typeface="IBM Plex Sans JP" panose="020B0503050203000203" pitchFamily="50" charset="-128"/>
+                <a:cs typeface="IBM Plex Sans JP"/>
+                <a:sym typeface="IBM Plex Sans JP"/>
+              </a:rPr>
+              <a:t>Check Filament </a:t>
+            </a:r>
+            <a:r>
+              <a:rPr lang="en-US" sz="1000" dirty="0" err="1">
+                <a:solidFill>
+                  <a:schemeClr val="dk1"/>
+                </a:solidFill>
+                <a:latin typeface="IBM Plex Sans JP" panose="020B0503050203000203" pitchFamily="50" charset="-128"/>
+                <a:ea typeface="IBM Plex Sans JP" panose="020B0503050203000203" pitchFamily="50" charset="-128"/>
+                <a:cs typeface="IBM Plex Sans JP"/>
+                <a:sym typeface="IBM Plex Sans JP"/>
+              </a:rPr>
+              <a:t>によってCheck</a:t>
+            </a:r>
+            <a:r>
+              <a:rPr lang="en-US" sz="1000" dirty="0">
+                <a:solidFill>
+                  <a:schemeClr val="dk1"/>
+                </a:solidFill>
+                <a:latin typeface="IBM Plex Sans JP" panose="020B0503050203000203" pitchFamily="50" charset="-128"/>
+                <a:ea typeface="IBM Plex Sans JP" panose="020B0503050203000203" pitchFamily="50" charset="-128"/>
+                <a:cs typeface="IBM Plex Sans JP"/>
+                <a:sym typeface="IBM Plex Sans JP"/>
+              </a:rPr>
+              <a:t> Tower </a:t>
+            </a:r>
+            <a:r>
+              <a:rPr lang="en-US" sz="1000" dirty="0" err="1">
+                <a:solidFill>
+                  <a:schemeClr val="dk1"/>
+                </a:solidFill>
+                <a:latin typeface="IBM Plex Sans JP" panose="020B0503050203000203" pitchFamily="50" charset="-128"/>
+                <a:ea typeface="IBM Plex Sans JP" panose="020B0503050203000203" pitchFamily="50" charset="-128"/>
+                <a:cs typeface="IBM Plex Sans JP"/>
+                <a:sym typeface="IBM Plex Sans JP"/>
+              </a:rPr>
+              <a:t>を印刷し、求める色に近い混合比を確認する</a:t>
+            </a:r>
+            <a:r>
+              <a:rPr lang="en-US" sz="1000" dirty="0">
+                <a:solidFill>
+                  <a:schemeClr val="dk1"/>
+                </a:solidFill>
+                <a:latin typeface="IBM Plex Sans JP" panose="020B0503050203000203" pitchFamily="50" charset="-128"/>
+                <a:ea typeface="IBM Plex Sans JP" panose="020B0503050203000203" pitchFamily="50" charset="-128"/>
+                <a:cs typeface="IBM Plex Sans JP"/>
+                <a:sym typeface="IBM Plex Sans JP"/>
+              </a:rPr>
+              <a:t> </a:t>
+            </a:r>
+            <a:endParaRPr sz="1000" dirty="0">
               <a:solidFill>
                 <a:schemeClr val="dk1"/>
               </a:solidFill>
@@ -16449,18 +16521,30 @@
               <a:buAutoNum type="arabicPeriod"/>
             </a:pPr>
             <a:r>
-              <a:rPr lang="en-US" sz="1000">
-                <a:solidFill>
-                  <a:schemeClr val="dk1"/>
-                </a:solidFill>
-                <a:latin typeface="IBM Plex Sans JP" panose="020B0503050203000203" pitchFamily="50" charset="-128"/>
-                <a:ea typeface="IBM Plex Sans JP" panose="020B0503050203000203" pitchFamily="50" charset="-128"/>
-                <a:cs typeface="IBM Plex Sans JP"/>
-                <a:sym typeface="IBM Plex Sans JP"/>
-              </a:rPr>
-              <a:t>必要に応じ ３の混合比のS4モデルを印刷し近似形状をテストプリントする </a:t>
-            </a:r>
-            <a:endParaRPr sz="1000">
+              <a:rPr lang="en-US" sz="1000" dirty="0" err="1">
+                <a:solidFill>
+                  <a:schemeClr val="dk1"/>
+                </a:solidFill>
+                <a:latin typeface="IBM Plex Sans JP" panose="020B0503050203000203" pitchFamily="50" charset="-128"/>
+                <a:ea typeface="IBM Plex Sans JP" panose="020B0503050203000203" pitchFamily="50" charset="-128"/>
+                <a:cs typeface="IBM Plex Sans JP"/>
+                <a:sym typeface="IBM Plex Sans JP"/>
+              </a:rPr>
+              <a:t>必要に応じ</a:t>
+            </a:r>
+            <a:r>
+              <a:rPr lang="en-US" sz="1000" dirty="0">
+                <a:solidFill>
+                  <a:schemeClr val="dk1"/>
+                </a:solidFill>
+                <a:latin typeface="IBM Plex Sans JP" panose="020B0503050203000203" pitchFamily="50" charset="-128"/>
+                <a:ea typeface="IBM Plex Sans JP" panose="020B0503050203000203" pitchFamily="50" charset="-128"/>
+                <a:cs typeface="IBM Plex Sans JP"/>
+                <a:sym typeface="IBM Plex Sans JP"/>
+              </a:rPr>
+              <a:t> ３の混合比のS4モデルを印刷し近似形状をテストプリントする </a:t>
+            </a:r>
+            <a:endParaRPr sz="1000" dirty="0">
               <a:solidFill>
                 <a:schemeClr val="dk1"/>
               </a:solidFill>
@@ -16489,18 +16573,78 @@
               <a:buAutoNum type="arabicPeriod"/>
             </a:pPr>
             <a:r>
-              <a:rPr lang="en-US" sz="1000">
-                <a:solidFill>
-                  <a:schemeClr val="dk1"/>
-                </a:solidFill>
-                <a:latin typeface="IBM Plex Sans JP" panose="020B0503050203000203" pitchFamily="50" charset="-128"/>
-                <a:ea typeface="IBM Plex Sans JP" panose="020B0503050203000203" pitchFamily="50" charset="-128"/>
-                <a:cs typeface="IBM Plex Sans JP"/>
-                <a:sym typeface="IBM Plex Sans JP"/>
-              </a:rPr>
-              <a:t>問題なければ 必要量の Blend Filament を生成する </a:t>
-            </a:r>
-            <a:endParaRPr sz="1000" b="1">
+              <a:rPr lang="en-US" sz="1000" dirty="0" err="1">
+                <a:solidFill>
+                  <a:schemeClr val="dk1"/>
+                </a:solidFill>
+                <a:latin typeface="IBM Plex Sans JP" panose="020B0503050203000203" pitchFamily="50" charset="-128"/>
+                <a:ea typeface="IBM Plex Sans JP" panose="020B0503050203000203" pitchFamily="50" charset="-128"/>
+                <a:cs typeface="IBM Plex Sans JP"/>
+                <a:sym typeface="IBM Plex Sans JP"/>
+              </a:rPr>
+              <a:t>問題なければ</a:t>
+            </a:r>
+            <a:r>
+              <a:rPr lang="en-US" sz="1000" dirty="0">
+                <a:solidFill>
+                  <a:schemeClr val="dk1"/>
+                </a:solidFill>
+                <a:latin typeface="IBM Plex Sans JP" panose="020B0503050203000203" pitchFamily="50" charset="-128"/>
+                <a:ea typeface="IBM Plex Sans JP" panose="020B0503050203000203" pitchFamily="50" charset="-128"/>
+                <a:cs typeface="IBM Plex Sans JP"/>
+                <a:sym typeface="IBM Plex Sans JP"/>
+              </a:rPr>
+              <a:t> </a:t>
+            </a:r>
+            <a:r>
+              <a:rPr lang="en-US" sz="1000" dirty="0" err="1">
+                <a:solidFill>
+                  <a:schemeClr val="dk1"/>
+                </a:solidFill>
+                <a:latin typeface="IBM Plex Sans JP" panose="020B0503050203000203" pitchFamily="50" charset="-128"/>
+                <a:ea typeface="IBM Plex Sans JP" panose="020B0503050203000203" pitchFamily="50" charset="-128"/>
+                <a:cs typeface="IBM Plex Sans JP"/>
+                <a:sym typeface="IBM Plex Sans JP"/>
+              </a:rPr>
+              <a:t>必要量の</a:t>
+            </a:r>
+            <a:r>
+              <a:rPr lang="en-US" sz="1000" dirty="0">
+                <a:solidFill>
+                  <a:schemeClr val="dk1"/>
+                </a:solidFill>
+                <a:latin typeface="IBM Plex Sans JP" panose="020B0503050203000203" pitchFamily="50" charset="-128"/>
+                <a:ea typeface="IBM Plex Sans JP" panose="020B0503050203000203" pitchFamily="50" charset="-128"/>
+                <a:cs typeface="IBM Plex Sans JP"/>
+                <a:sym typeface="IBM Plex Sans JP"/>
+              </a:rPr>
+              <a:t> Blend Filament </a:t>
+            </a:r>
+            <a:r>
+              <a:rPr lang="en-US" sz="1000" dirty="0" err="1">
+                <a:solidFill>
+                  <a:schemeClr val="dk1"/>
+                </a:solidFill>
+                <a:latin typeface="IBM Plex Sans JP" panose="020B0503050203000203" pitchFamily="50" charset="-128"/>
+                <a:ea typeface="IBM Plex Sans JP" panose="020B0503050203000203" pitchFamily="50" charset="-128"/>
+                <a:cs typeface="IBM Plex Sans JP"/>
+                <a:sym typeface="IBM Plex Sans JP"/>
+              </a:rPr>
+              <a:t>を生成する</a:t>
+            </a:r>
+            <a:r>
+              <a:rPr lang="en-US" sz="1000" dirty="0">
+                <a:solidFill>
+                  <a:schemeClr val="dk1"/>
+                </a:solidFill>
+                <a:latin typeface="IBM Plex Sans JP" panose="020B0503050203000203" pitchFamily="50" charset="-128"/>
+                <a:ea typeface="IBM Plex Sans JP" panose="020B0503050203000203" pitchFamily="50" charset="-128"/>
+                <a:cs typeface="IBM Plex Sans JP"/>
+                <a:sym typeface="IBM Plex Sans JP"/>
+              </a:rPr>
+              <a:t> </a:t>
+            </a:r>
+            <a:endParaRPr sz="1000" b="1" dirty="0">
               <a:solidFill>
                 <a:schemeClr val="dk1"/>
               </a:solidFill>
@@ -24020,7 +24164,7 @@
               <a:buAutoNum type="arabicPeriod"/>
             </a:pPr>
             <a:r>
-              <a:rPr lang="en-US" sz="1000">
+              <a:rPr lang="en-US" sz="1000" dirty="0">
                 <a:solidFill>
                   <a:schemeClr val="dk1"/>
                 </a:solidFill>
@@ -24031,7 +24175,7 @@
               </a:rPr>
               <a:t>欲しい色を実現できそうな2色のフィラメントを選定する </a:t>
             </a:r>
-            <a:endParaRPr sz="1000">
+            <a:endParaRPr sz="1000" dirty="0">
               <a:solidFill>
                 <a:schemeClr val="dk1"/>
               </a:solidFill>
@@ -24060,18 +24204,42 @@
               <a:buAutoNum type="arabicPeriod"/>
             </a:pPr>
             <a:r>
-              <a:rPr lang="en-US" sz="1000">
-                <a:solidFill>
-                  <a:schemeClr val="dk1"/>
-                </a:solidFill>
-                <a:latin typeface="IBM Plex Sans JP" panose="020B0503050203000203" pitchFamily="50" charset="-128"/>
-                <a:ea typeface="IBM Plex Sans JP" panose="020B0503050203000203" pitchFamily="50" charset="-128"/>
-                <a:cs typeface="IBM Plex Sans JP"/>
-                <a:sym typeface="IBM Plex Sans JP"/>
-              </a:rPr>
-              <a:t>1のフィラメントを用いてCheck Filament を印刷する </a:t>
-            </a:r>
-            <a:endParaRPr sz="1000">
+              <a:rPr lang="en-US" sz="1000" dirty="0">
+                <a:solidFill>
+                  <a:schemeClr val="dk1"/>
+                </a:solidFill>
+                <a:latin typeface="IBM Plex Sans JP" panose="020B0503050203000203" pitchFamily="50" charset="-128"/>
+                <a:ea typeface="IBM Plex Sans JP" panose="020B0503050203000203" pitchFamily="50" charset="-128"/>
+                <a:cs typeface="IBM Plex Sans JP"/>
+                <a:sym typeface="IBM Plex Sans JP"/>
+              </a:rPr>
+              <a:t>1のフィラメントを用いてCheck Filament </a:t>
+            </a:r>
+            <a:r>
+              <a:rPr lang="en-US" sz="1000" dirty="0" err="1">
+                <a:solidFill>
+                  <a:schemeClr val="dk1"/>
+                </a:solidFill>
+                <a:latin typeface="IBM Plex Sans JP" panose="020B0503050203000203" pitchFamily="50" charset="-128"/>
+                <a:ea typeface="IBM Plex Sans JP" panose="020B0503050203000203" pitchFamily="50" charset="-128"/>
+                <a:cs typeface="IBM Plex Sans JP"/>
+                <a:sym typeface="IBM Plex Sans JP"/>
+              </a:rPr>
+              <a:t>を印刷する</a:t>
+            </a:r>
+            <a:r>
+              <a:rPr lang="en-US" sz="1000" dirty="0">
+                <a:solidFill>
+                  <a:schemeClr val="dk1"/>
+                </a:solidFill>
+                <a:latin typeface="IBM Plex Sans JP" panose="020B0503050203000203" pitchFamily="50" charset="-128"/>
+                <a:ea typeface="IBM Plex Sans JP" panose="020B0503050203000203" pitchFamily="50" charset="-128"/>
+                <a:cs typeface="IBM Plex Sans JP"/>
+                <a:sym typeface="IBM Plex Sans JP"/>
+              </a:rPr>
+              <a:t> </a:t>
+            </a:r>
+            <a:endParaRPr sz="1000" dirty="0">
               <a:solidFill>
                 <a:schemeClr val="dk1"/>
               </a:solidFill>
@@ -24100,18 +24268,66 @@
               <a:buAutoNum type="arabicPeriod"/>
             </a:pPr>
             <a:r>
-              <a:rPr lang="en-US" sz="1000">
-                <a:solidFill>
-                  <a:schemeClr val="dk1"/>
-                </a:solidFill>
-                <a:latin typeface="IBM Plex Sans JP" panose="020B0503050203000203" pitchFamily="50" charset="-128"/>
-                <a:ea typeface="IBM Plex Sans JP" panose="020B0503050203000203" pitchFamily="50" charset="-128"/>
-                <a:cs typeface="IBM Plex Sans JP"/>
-                <a:sym typeface="IBM Plex Sans JP"/>
-              </a:rPr>
-              <a:t>Check Filament によってCheck Tower を印刷し、求める色に近いう混合比を確認する </a:t>
-            </a:r>
-            <a:endParaRPr sz="1000">
+              <a:rPr lang="en-US" sz="1000" dirty="0">
+                <a:solidFill>
+                  <a:schemeClr val="dk1"/>
+                </a:solidFill>
+                <a:latin typeface="IBM Plex Sans JP" panose="020B0503050203000203" pitchFamily="50" charset="-128"/>
+                <a:ea typeface="IBM Plex Sans JP" panose="020B0503050203000203" pitchFamily="50" charset="-128"/>
+                <a:cs typeface="IBM Plex Sans JP"/>
+                <a:sym typeface="IBM Plex Sans JP"/>
+              </a:rPr>
+              <a:t>Check Filament </a:t>
+            </a:r>
+            <a:r>
+              <a:rPr lang="en-US" sz="1000" dirty="0" err="1">
+                <a:solidFill>
+                  <a:schemeClr val="dk1"/>
+                </a:solidFill>
+                <a:latin typeface="IBM Plex Sans JP" panose="020B0503050203000203" pitchFamily="50" charset="-128"/>
+                <a:ea typeface="IBM Plex Sans JP" panose="020B0503050203000203" pitchFamily="50" charset="-128"/>
+                <a:cs typeface="IBM Plex Sans JP"/>
+                <a:sym typeface="IBM Plex Sans JP"/>
+              </a:rPr>
+              <a:t>によってCheck</a:t>
+            </a:r>
+            <a:r>
+              <a:rPr lang="en-US" sz="1000" dirty="0">
+                <a:solidFill>
+                  <a:schemeClr val="dk1"/>
+                </a:solidFill>
+                <a:latin typeface="IBM Plex Sans JP" panose="020B0503050203000203" pitchFamily="50" charset="-128"/>
+                <a:ea typeface="IBM Plex Sans JP" panose="020B0503050203000203" pitchFamily="50" charset="-128"/>
+                <a:cs typeface="IBM Plex Sans JP"/>
+                <a:sym typeface="IBM Plex Sans JP"/>
+              </a:rPr>
+              <a:t> Tower </a:t>
+            </a:r>
+            <a:r>
+              <a:rPr lang="en-US" sz="1000" dirty="0" err="1">
+                <a:solidFill>
+                  <a:schemeClr val="dk1"/>
+                </a:solidFill>
+                <a:latin typeface="IBM Plex Sans JP" panose="020B0503050203000203" pitchFamily="50" charset="-128"/>
+                <a:ea typeface="IBM Plex Sans JP" panose="020B0503050203000203" pitchFamily="50" charset="-128"/>
+                <a:cs typeface="IBM Plex Sans JP"/>
+                <a:sym typeface="IBM Plex Sans JP"/>
+              </a:rPr>
+              <a:t>を印刷し、求める色に近い混合比を確認する</a:t>
+            </a:r>
+            <a:r>
+              <a:rPr lang="en-US" sz="1000" dirty="0">
+                <a:solidFill>
+                  <a:schemeClr val="dk1"/>
+                </a:solidFill>
+                <a:latin typeface="IBM Plex Sans JP" panose="020B0503050203000203" pitchFamily="50" charset="-128"/>
+                <a:ea typeface="IBM Plex Sans JP" panose="020B0503050203000203" pitchFamily="50" charset="-128"/>
+                <a:cs typeface="IBM Plex Sans JP"/>
+                <a:sym typeface="IBM Plex Sans JP"/>
+              </a:rPr>
+              <a:t> </a:t>
+            </a:r>
+            <a:endParaRPr sz="1000" dirty="0">
               <a:solidFill>
                 <a:schemeClr val="dk1"/>
               </a:solidFill>
@@ -24140,18 +24356,30 @@
               <a:buAutoNum type="arabicPeriod"/>
             </a:pPr>
             <a:r>
-              <a:rPr lang="en-US" sz="1000">
-                <a:solidFill>
-                  <a:schemeClr val="dk1"/>
-                </a:solidFill>
-                <a:latin typeface="IBM Plex Sans JP" panose="020B0503050203000203" pitchFamily="50" charset="-128"/>
-                <a:ea typeface="IBM Plex Sans JP" panose="020B0503050203000203" pitchFamily="50" charset="-128"/>
-                <a:cs typeface="IBM Plex Sans JP"/>
-                <a:sym typeface="IBM Plex Sans JP"/>
-              </a:rPr>
-              <a:t>必要に応じ ３の混合比のS4モデルを印刷し近似形状をテストプリントする </a:t>
-            </a:r>
-            <a:endParaRPr sz="1000">
+              <a:rPr lang="en-US" sz="1000" dirty="0" err="1">
+                <a:solidFill>
+                  <a:schemeClr val="dk1"/>
+                </a:solidFill>
+                <a:latin typeface="IBM Plex Sans JP" panose="020B0503050203000203" pitchFamily="50" charset="-128"/>
+                <a:ea typeface="IBM Plex Sans JP" panose="020B0503050203000203" pitchFamily="50" charset="-128"/>
+                <a:cs typeface="IBM Plex Sans JP"/>
+                <a:sym typeface="IBM Plex Sans JP"/>
+              </a:rPr>
+              <a:t>必要に応じ</a:t>
+            </a:r>
+            <a:r>
+              <a:rPr lang="en-US" sz="1000" dirty="0">
+                <a:solidFill>
+                  <a:schemeClr val="dk1"/>
+                </a:solidFill>
+                <a:latin typeface="IBM Plex Sans JP" panose="020B0503050203000203" pitchFamily="50" charset="-128"/>
+                <a:ea typeface="IBM Plex Sans JP" panose="020B0503050203000203" pitchFamily="50" charset="-128"/>
+                <a:cs typeface="IBM Plex Sans JP"/>
+                <a:sym typeface="IBM Plex Sans JP"/>
+              </a:rPr>
+              <a:t> ３の混合比のS4モデルを印刷し近似形状をテストプリントする </a:t>
+            </a:r>
+            <a:endParaRPr sz="1000" dirty="0">
               <a:solidFill>
                 <a:schemeClr val="dk1"/>
               </a:solidFill>
@@ -24180,18 +24408,78 @@
               <a:buAutoNum type="arabicPeriod"/>
             </a:pPr>
             <a:r>
-              <a:rPr lang="en-US" sz="1000">
-                <a:solidFill>
-                  <a:schemeClr val="dk1"/>
-                </a:solidFill>
-                <a:latin typeface="IBM Plex Sans JP" panose="020B0503050203000203" pitchFamily="50" charset="-128"/>
-                <a:ea typeface="IBM Plex Sans JP" panose="020B0503050203000203" pitchFamily="50" charset="-128"/>
-                <a:cs typeface="IBM Plex Sans JP"/>
-                <a:sym typeface="IBM Plex Sans JP"/>
-              </a:rPr>
-              <a:t>問題なければ 必要量の Blend Filament を生成する </a:t>
-            </a:r>
-            <a:endParaRPr sz="1000" b="1">
+              <a:rPr lang="en-US" sz="1000" dirty="0" err="1">
+                <a:solidFill>
+                  <a:schemeClr val="dk1"/>
+                </a:solidFill>
+                <a:latin typeface="IBM Plex Sans JP" panose="020B0503050203000203" pitchFamily="50" charset="-128"/>
+                <a:ea typeface="IBM Plex Sans JP" panose="020B0503050203000203" pitchFamily="50" charset="-128"/>
+                <a:cs typeface="IBM Plex Sans JP"/>
+                <a:sym typeface="IBM Plex Sans JP"/>
+              </a:rPr>
+              <a:t>問題なければ</a:t>
+            </a:r>
+            <a:r>
+              <a:rPr lang="en-US" sz="1000" dirty="0">
+                <a:solidFill>
+                  <a:schemeClr val="dk1"/>
+                </a:solidFill>
+                <a:latin typeface="IBM Plex Sans JP" panose="020B0503050203000203" pitchFamily="50" charset="-128"/>
+                <a:ea typeface="IBM Plex Sans JP" panose="020B0503050203000203" pitchFamily="50" charset="-128"/>
+                <a:cs typeface="IBM Plex Sans JP"/>
+                <a:sym typeface="IBM Plex Sans JP"/>
+              </a:rPr>
+              <a:t> </a:t>
+            </a:r>
+            <a:r>
+              <a:rPr lang="en-US" sz="1000" dirty="0" err="1">
+                <a:solidFill>
+                  <a:schemeClr val="dk1"/>
+                </a:solidFill>
+                <a:latin typeface="IBM Plex Sans JP" panose="020B0503050203000203" pitchFamily="50" charset="-128"/>
+                <a:ea typeface="IBM Plex Sans JP" panose="020B0503050203000203" pitchFamily="50" charset="-128"/>
+                <a:cs typeface="IBM Plex Sans JP"/>
+                <a:sym typeface="IBM Plex Sans JP"/>
+              </a:rPr>
+              <a:t>必要量の</a:t>
+            </a:r>
+            <a:r>
+              <a:rPr lang="en-US" sz="1000" dirty="0">
+                <a:solidFill>
+                  <a:schemeClr val="dk1"/>
+                </a:solidFill>
+                <a:latin typeface="IBM Plex Sans JP" panose="020B0503050203000203" pitchFamily="50" charset="-128"/>
+                <a:ea typeface="IBM Plex Sans JP" panose="020B0503050203000203" pitchFamily="50" charset="-128"/>
+                <a:cs typeface="IBM Plex Sans JP"/>
+                <a:sym typeface="IBM Plex Sans JP"/>
+              </a:rPr>
+              <a:t> Blend Filament </a:t>
+            </a:r>
+            <a:r>
+              <a:rPr lang="en-US" sz="1000" dirty="0" err="1">
+                <a:solidFill>
+                  <a:schemeClr val="dk1"/>
+                </a:solidFill>
+                <a:latin typeface="IBM Plex Sans JP" panose="020B0503050203000203" pitchFamily="50" charset="-128"/>
+                <a:ea typeface="IBM Plex Sans JP" panose="020B0503050203000203" pitchFamily="50" charset="-128"/>
+                <a:cs typeface="IBM Plex Sans JP"/>
+                <a:sym typeface="IBM Plex Sans JP"/>
+              </a:rPr>
+              <a:t>を生成する</a:t>
+            </a:r>
+            <a:r>
+              <a:rPr lang="en-US" sz="1000" dirty="0">
+                <a:solidFill>
+                  <a:schemeClr val="dk1"/>
+                </a:solidFill>
+                <a:latin typeface="IBM Plex Sans JP" panose="020B0503050203000203" pitchFamily="50" charset="-128"/>
+                <a:ea typeface="IBM Plex Sans JP" panose="020B0503050203000203" pitchFamily="50" charset="-128"/>
+                <a:cs typeface="IBM Plex Sans JP"/>
+                <a:sym typeface="IBM Plex Sans JP"/>
+              </a:rPr>
+              <a:t> </a:t>
+            </a:r>
+            <a:endParaRPr sz="1000" b="1" dirty="0">
               <a:solidFill>
                 <a:schemeClr val="dk1"/>
               </a:solidFill>

</xml_diff>